<commit_message>
Add files and edit figures
</commit_message>
<xml_diff>
--- a/graphical_abstract/ATR_graphical_abstract_rr2.pptx
+++ b/graphical_abstract/ATR_graphical_abstract_rr2.pptx
@@ -121,14 +121,6 @@
 </p188:authorLst>
 </file>
 
-<file path=ppt/revisionInfo.xml><?xml version="1.0" encoding="utf-8"?>
-<p1510:revInfo xmlns:a="http://schemas.openxmlformats.org/drawingml/2006/main" xmlns:r="http://schemas.openxmlformats.org/officeDocument/2006/relationships" xmlns:p1510="http://schemas.microsoft.com/office/powerpoint/2015/10/main">
-  <p1510:revLst>
-    <p1510:client id="{11A3ECB7-1AEB-FA4B-928C-D7613C68ACDC}" v="2" dt="2026-04-29T12:26:17.020"/>
-  </p1510:revLst>
-</p1510:revInfo>
-</file>
-
 <file path=ppt/comments/modernComment_100_9EAEF6A1.xml><?xml version="1.0" encoding="utf-8"?>
 <p188:cmLst xmlns:a="http://schemas.openxmlformats.org/drawingml/2006/main" xmlns:r="http://schemas.openxmlformats.org/officeDocument/2006/relationships" xmlns:p188="http://schemas.microsoft.com/office/powerpoint/2018/8/main">
   <p188:cm id="{F1C0D903-0619-41C8-A8AA-C9B2FB3911FA}" authorId="{F18038FE-C879-9321-9A02-E4E2ED79FCDF}" status="resolved" created="2026-04-28T13:26:09.781" complete="100000">
@@ -154,6 +146,7 @@
       <pc:sldMk xmlns:pc="http://schemas.microsoft.com/office/powerpoint/2013/main/command" cId="2662266529" sldId="256"/>
       <ac:spMk id="9" creationId="{405FE8D1-E98D-8837-B4D4-0A66670C438B}"/>
     </ac:deMkLst>
+    <p188:replyLst/>
     <p188:txBody>
       <a:bodyPr/>
       <a:lstStyle/>
@@ -205,6 +198,20 @@
       <pc:sldMk xmlns:pc="http://schemas.microsoft.com/office/powerpoint/2013/main/command" cId="2662266529" sldId="256"/>
       <ac:spMk id="35" creationId="{1F514C6A-8E93-C0FE-F9EC-867C5D0D001C}"/>
     </ac:deMkLst>
+    <p188:replyLst>
+      <p188:reply id="{9021E010-27B5-4657-AEA6-6A4A38833891}" authorId="{F18038FE-C879-9321-9A02-E4E2ED79FCDF}" created="2026-04-30T14:35:10.026">
+        <p188:txBody>
+          <a:bodyPr/>
+          <a:lstStyle/>
+          <a:p>
+            <a:r>
+              <a:rPr lang="en-NL"/>
+              <a:t>Wellicht laatste zin: … which are further enhanced when incomes increase.</a:t>
+            </a:r>
+          </a:p>
+        </p188:txBody>
+      </p188:reply>
+    </p188:replyLst>
     <p188:txBody>
       <a:bodyPr/>
       <a:lstStyle/>
@@ -212,6 +219,41 @@
         <a:r>
           <a:rPr lang="nl-NL"/>
           <a:t>Ik twijfel hier over opnemen van inkomenseffect. En hier hebben we het over share of tourists travelling long distances is increasing in distance. Probably the best way to describe. See also abstract and highlights. </a:t>
+        </a:r>
+      </a:p>
+    </p188:txBody>
+  </p188:cm>
+  <p188:cm id="{C5069E7B-9E5B-45E4-A300-E144478A1E46}" authorId="{F18038FE-C879-9321-9A02-E4E2ED79FCDF}" status="resolved" created="2026-04-30T14:42:43.788" complete="100000">
+    <ac:deMkLst xmlns:ac="http://schemas.microsoft.com/office/drawing/2013/main/command">
+      <pc:docMk xmlns:pc="http://schemas.microsoft.com/office/powerpoint/2013/main/command"/>
+      <pc:sldMk xmlns:pc="http://schemas.microsoft.com/office/powerpoint/2013/main/command" cId="2662266529" sldId="256"/>
+      <ac:picMk id="12" creationId="{D4D590FC-2E2B-A2AA-260B-7EE987B4B8A7}"/>
+    </ac:deMkLst>
+    <p188:txBody>
+      <a:bodyPr/>
+      <a:lstStyle/>
+      <a:p>
+        <a:r>
+          <a:rPr lang="en-NL"/>
+          <a:t>Check bij rechter figuur: Fraction ipv share of op verticale as percentages zetten. Klopt het dat som balkjes optelt tot 1 (en gemiddelde dus gelijk is aan 5%? </a:t>
+        </a:r>
+      </a:p>
+    </p188:txBody>
+  </p188:cm>
+  <p188:cm id="{862496B2-A4DC-4E52-AB89-07E9ABCA6CE7}" authorId="{F18038FE-C879-9321-9A02-E4E2ED79FCDF}" created="2026-04-30T14:43:58.807">
+    <ac:deMkLst xmlns:ac="http://schemas.microsoft.com/office/drawing/2013/main/command">
+      <pc:docMk xmlns:pc="http://schemas.microsoft.com/office/powerpoint/2013/main/command"/>
+      <pc:sldMk xmlns:pc="http://schemas.microsoft.com/office/powerpoint/2013/main/command" cId="2662266529" sldId="256"/>
+      <ac:picMk id="12" creationId="{D4D590FC-2E2B-A2AA-260B-7EE987B4B8A7}"/>
+    </ac:deMkLst>
+    <p188:txBody>
+      <a:bodyPr/>
+      <a:lstStyle/>
+      <a:p>
+        <a:r>
+          <a:rPr lang="en-NL"/>
+          <a:t>Middelste figuur is links iets te scherp afgesneden waardoor tekst niet helemaal zichtbaar is. En eigenlijk zou er nog een legenda bij moeten. 
+</a:t>
         </a:r>
       </a:p>
     </p188:txBody>
@@ -301,7 +343,7 @@
           <a:p>
             <a:fld id="{6E43AAD3-71D7-AC4B-8EF7-D8DD7F1D7D5D}" type="datetimeFigureOut">
               <a:rPr lang="en-US" smtClean="0"/>
-              <a:t>4/29/26</a:t>
+              <a:t>5/1/26</a:t>
             </a:fld>
             <a:endParaRPr lang="en-US"/>
           </a:p>
@@ -784,7 +826,7 @@
           <a:p>
             <a:fld id="{D0356222-9F14-664A-BDE1-9B3FD3BCA485}" type="datetimeFigureOut">
               <a:rPr lang="en-US" smtClean="0"/>
-              <a:t>4/29/26</a:t>
+              <a:t>5/1/26</a:t>
             </a:fld>
             <a:endParaRPr lang="en-US"/>
           </a:p>
@@ -954,7 +996,7 @@
           <a:p>
             <a:fld id="{D0356222-9F14-664A-BDE1-9B3FD3BCA485}" type="datetimeFigureOut">
               <a:rPr lang="en-US" smtClean="0"/>
-              <a:t>4/29/26</a:t>
+              <a:t>5/1/26</a:t>
             </a:fld>
             <a:endParaRPr lang="en-US"/>
           </a:p>
@@ -1134,7 +1176,7 @@
           <a:p>
             <a:fld id="{D0356222-9F14-664A-BDE1-9B3FD3BCA485}" type="datetimeFigureOut">
               <a:rPr lang="en-US" smtClean="0"/>
-              <a:t>4/29/26</a:t>
+              <a:t>5/1/26</a:t>
             </a:fld>
             <a:endParaRPr lang="en-US"/>
           </a:p>
@@ -1304,7 +1346,7 @@
           <a:p>
             <a:fld id="{D0356222-9F14-664A-BDE1-9B3FD3BCA485}" type="datetimeFigureOut">
               <a:rPr lang="en-US" smtClean="0"/>
-              <a:t>4/29/26</a:t>
+              <a:t>5/1/26</a:t>
             </a:fld>
             <a:endParaRPr lang="en-US"/>
           </a:p>
@@ -1550,7 +1592,7 @@
           <a:p>
             <a:fld id="{D0356222-9F14-664A-BDE1-9B3FD3BCA485}" type="datetimeFigureOut">
               <a:rPr lang="en-US" smtClean="0"/>
-              <a:t>4/29/26</a:t>
+              <a:t>5/1/26</a:t>
             </a:fld>
             <a:endParaRPr lang="en-US"/>
           </a:p>
@@ -1782,7 +1824,7 @@
           <a:p>
             <a:fld id="{D0356222-9F14-664A-BDE1-9B3FD3BCA485}" type="datetimeFigureOut">
               <a:rPr lang="en-US" smtClean="0"/>
-              <a:t>4/29/26</a:t>
+              <a:t>5/1/26</a:t>
             </a:fld>
             <a:endParaRPr lang="en-US"/>
           </a:p>
@@ -2149,7 +2191,7 @@
           <a:p>
             <a:fld id="{D0356222-9F14-664A-BDE1-9B3FD3BCA485}" type="datetimeFigureOut">
               <a:rPr lang="en-US" smtClean="0"/>
-              <a:t>4/29/26</a:t>
+              <a:t>5/1/26</a:t>
             </a:fld>
             <a:endParaRPr lang="en-US"/>
           </a:p>
@@ -2267,7 +2309,7 @@
           <a:p>
             <a:fld id="{D0356222-9F14-664A-BDE1-9B3FD3BCA485}" type="datetimeFigureOut">
               <a:rPr lang="en-US" smtClean="0"/>
-              <a:t>4/29/26</a:t>
+              <a:t>5/1/26</a:t>
             </a:fld>
             <a:endParaRPr lang="en-US"/>
           </a:p>
@@ -2362,7 +2404,7 @@
           <a:p>
             <a:fld id="{D0356222-9F14-664A-BDE1-9B3FD3BCA485}" type="datetimeFigureOut">
               <a:rPr lang="en-US" smtClean="0"/>
-              <a:t>4/29/26</a:t>
+              <a:t>5/1/26</a:t>
             </a:fld>
             <a:endParaRPr lang="en-US"/>
           </a:p>
@@ -2639,7 +2681,7 @@
           <a:p>
             <a:fld id="{D0356222-9F14-664A-BDE1-9B3FD3BCA485}" type="datetimeFigureOut">
               <a:rPr lang="en-US" smtClean="0"/>
-              <a:t>4/29/26</a:t>
+              <a:t>5/1/26</a:t>
             </a:fld>
             <a:endParaRPr lang="en-US"/>
           </a:p>
@@ -2896,7 +2938,7 @@
           <a:p>
             <a:fld id="{D0356222-9F14-664A-BDE1-9B3FD3BCA485}" type="datetimeFigureOut">
               <a:rPr lang="en-US" smtClean="0"/>
-              <a:t>4/29/26</a:t>
+              <a:t>5/1/26</a:t>
             </a:fld>
             <a:endParaRPr lang="en-US"/>
           </a:p>
@@ -3109,7 +3151,7 @@
           <a:p>
             <a:fld id="{D0356222-9F14-664A-BDE1-9B3FD3BCA485}" type="datetimeFigureOut">
               <a:rPr lang="en-US" smtClean="0"/>
-              <a:t>4/29/26</a:t>
+              <a:t>5/1/26</a:t>
             </a:fld>
             <a:endParaRPr lang="en-US"/>
           </a:p>
@@ -3738,7 +3780,15 @@
           <a:p>
             <a:r>
               <a:rPr lang="en-US" sz="1200" dirty="0"/>
-              <a:t>This meta-analysis summarizes and explains the variation in the </a:t>
+              <a:t>This </a:t>
+            </a:r>
+            <a:r>
+              <a:rPr lang="en-US" sz="1200" b="1" dirty="0"/>
+              <a:t>meta-analysis</a:t>
+            </a:r>
+            <a:r>
+              <a:rPr lang="en-US" sz="1200" dirty="0"/>
+              <a:t> summarizes and explains the variation in the </a:t>
             </a:r>
             <a:r>
               <a:rPr lang="en-US" sz="1200" b="1" dirty="0"/>
@@ -3754,7 +3804,17 @@
             </a:r>
             <a:r>
               <a:rPr lang="en-US" sz="1200" dirty="0"/>
-              <a:t> distance-decay elasticity of -0.82.</a:t>
+              <a:t> distance-decay elasticity of </a:t>
+            </a:r>
+            <a:r>
+              <a:rPr lang="en-US" sz="1200" dirty="0">
+                <a:latin typeface="Aptos Narrow" panose="020B0004020202020204" pitchFamily="34" charset="0"/>
+              </a:rPr>
+              <a:t>−</a:t>
+            </a:r>
+            <a:r>
+              <a:rPr lang="en-US" sz="1200" dirty="0"/>
+              <a:t>0.82.</a:t>
             </a:r>
           </a:p>
         </p:txBody>
@@ -3802,7 +3862,7 @@
             <a:pPr algn="just"/>
             <a:r>
               <a:rPr lang="en-US" sz="1000" dirty="0"/>
-              <a:t>when controlling for </a:t>
+              <a:t>…when controlling for </a:t>
             </a:r>
             <a:r>
               <a:rPr lang="en-US" sz="1000" b="1" dirty="0"/>
@@ -3810,7 +3870,7 @@
             </a:r>
             <a:r>
               <a:rPr lang="en-US" sz="1000" dirty="0"/>
-              <a:t> factors, such as island destinations     , sea access     , and  world heritage sites   , the distance-decay effect becomes smaller. </a:t>
+              <a:t> factors, such as island destinations     , sea access     , and  world heritage sites   , the distance-decay effect becomes smaller … </a:t>
             </a:r>
           </a:p>
         </p:txBody>
@@ -3876,7 +3936,7 @@
                   <a:sysClr val="windowText" lastClr="000000"/>
                 </a:solidFill>
               </a:rPr>
-              <a:t>Where …</a:t>
+              <a:t>… while …</a:t>
             </a:r>
           </a:p>
         </p:txBody>
@@ -3895,8 +3955,8 @@
         </p:nvSpPr>
         <p:spPr>
           <a:xfrm>
-            <a:off x="5860464" y="2629635"/>
-            <a:ext cx="1044000" cy="254000"/>
+            <a:off x="5872038" y="2629635"/>
+            <a:ext cx="1107495" cy="243290"/>
           </a:xfrm>
           <a:prstGeom prst="homePlate">
             <a:avLst/>
@@ -3942,7 +4002,7 @@
                   <a:sysClr val="windowText" lastClr="000000"/>
                 </a:solidFill>
               </a:rPr>
-              <a:t>Resulting in …</a:t>
+              <a:t>… resulting in …</a:t>
             </a:r>
           </a:p>
         </p:txBody>
@@ -4037,7 +4097,7 @@
         </p:blipFill>
         <p:spPr>
           <a:xfrm>
-            <a:off x="1603148" y="3216427"/>
+            <a:off x="1872481" y="3200023"/>
             <a:ext cx="144000" cy="144000"/>
           </a:xfrm>
           <a:prstGeom prst="rect">
@@ -4073,7 +4133,7 @@
         </p:blipFill>
         <p:spPr>
           <a:xfrm>
-            <a:off x="1527948" y="3365398"/>
+            <a:off x="1872481" y="3360427"/>
             <a:ext cx="144000" cy="144000"/>
           </a:xfrm>
           <a:prstGeom prst="rect">
@@ -4109,7 +4169,7 @@
         </p:blipFill>
         <p:spPr>
           <a:xfrm>
-            <a:off x="2435882" y="3216427"/>
+            <a:off x="2699848" y="3200023"/>
             <a:ext cx="144000" cy="144000"/>
           </a:xfrm>
           <a:prstGeom prst="rect">
@@ -4160,7 +4220,7 @@
             <a:pPr algn="just"/>
             <a:r>
               <a:rPr lang="en-US" sz="1000" dirty="0"/>
-              <a:t>the distance-decay effect remains </a:t>
+              <a:t>…the distance-decay effect remains </a:t>
             </a:r>
             <a:r>
               <a:rPr lang="en-US" sz="1000" b="1" dirty="0"/>
@@ -4168,7 +4228,7 @@
             </a:r>
             <a:r>
               <a:rPr lang="en-US" sz="1000" dirty="0"/>
-              <a:t> over time, both for domestic  and for international tourism      . </a:t>
+              <a:t> over time, both for domestic  and for international tourism      …</a:t>
             </a:r>
           </a:p>
         </p:txBody>
@@ -4216,7 +4276,7 @@
             <a:pPr algn="just"/>
             <a:r>
               <a:rPr lang="en-GB" sz="1000" dirty="0"/>
-              <a:t>the tourist share in the total trip number increases in distance, </a:t>
+              <a:t>… the tourist share in the total trip number increasing in distance, </a:t>
             </a:r>
             <a:r>
               <a:rPr lang="en-US" sz="1000" dirty="0"/>
@@ -4224,7 +4284,7 @@
             </a:r>
             <a:r>
               <a:rPr lang="en-GB" sz="1000" dirty="0"/>
-              <a:t>potentially severe environmental effects  , especially when incomes        increase</a:t>
+              <a:t>potentially severe environmental effects   , which are further enhanced  when incomes        increase</a:t>
             </a:r>
             <a:r>
               <a:rPr lang="en-US" sz="1000" dirty="0"/>
@@ -4297,7 +4357,7 @@
         </p:blipFill>
         <p:spPr>
           <a:xfrm>
-            <a:off x="8033565" y="3344023"/>
+            <a:off x="8008165" y="3344023"/>
             <a:ext cx="144000" cy="144000"/>
           </a:xfrm>
           <a:prstGeom prst="rect">
@@ -4333,7 +4393,7 @@
         </p:blipFill>
         <p:spPr>
           <a:xfrm>
-            <a:off x="7254541" y="3509398"/>
+            <a:off x="8177565" y="3506642"/>
             <a:ext cx="144000" cy="144000"/>
           </a:xfrm>
           <a:prstGeom prst="rect">
@@ -4423,15 +4483,15 @@
         </p:nvPicPr>
         <p:blipFill>
           <a:blip r:embed="rId10"/>
-          <a:srcRect l="2254" t="1753" r="1330" b="1161"/>
+          <a:srcRect l="1052" t="1753" r="1765" b="1161"/>
           <a:stretch>
             <a:fillRect/>
           </a:stretch>
         </p:blipFill>
         <p:spPr>
           <a:xfrm>
-            <a:off x="3369004" y="606397"/>
-            <a:ext cx="2507178" cy="2209203"/>
+            <a:off x="3374504" y="606397"/>
+            <a:ext cx="2484000" cy="2188780"/>
           </a:xfrm>
           <a:prstGeom prst="rect">
             <a:avLst/>

</xml_diff>